<commit_message>
feat(submission): add 12-slide competitive advantage matrix, static route mounts, and updated submission artifacts
</commit_message>
<xml_diff>
--- a/submission_files/OmniCare_AI_Executive_Presentation.pptx
+++ b/submission_files/OmniCare_AI_Executive_Presentation.pptx
@@ -16,6 +16,7 @@
     <p:sldId id="264" r:id="rId15"/>
     <p:sldId id="265" r:id="rId16"/>
     <p:sldId id="266" r:id="rId17"/>
+    <p:sldId id="267" r:id="rId18"/>
   </p:sldIdLst>
   <p:sldSz cx="12191695" cy="6858000" type="screen4x3"/>
   <p:notesSz cx="6858000" cy="9144000"/>
@@ -3778,6 +3779,1007 @@
 </file>
 
 <file path=ppt/slides/slide11.xml><?xml version="1.0" encoding="utf-8"?>
+<p:sld xmlns:a="http://schemas.openxmlformats.org/drawingml/2006/main" xmlns:p="http://schemas.openxmlformats.org/presentationml/2006/main" xmlns:r="http://schemas.openxmlformats.org/officeDocument/2006/relationships">
+  <p:cSld>
+    <p:spTree>
+      <p:nvGrpSpPr>
+        <p:cNvPr id="1" name=""/>
+        <p:cNvGrpSpPr/>
+        <p:nvPr/>
+      </p:nvGrpSpPr>
+      <p:grpSpPr/>
+      <p:sp>
+        <p:nvSpPr>
+          <p:cNvPr id="2" name="Rectangle 1"/>
+          <p:cNvSpPr/>
+          <p:nvPr/>
+        </p:nvSpPr>
+        <p:spPr>
+          <a:xfrm>
+            <a:off x="0" y="0"/>
+            <a:ext cx="12191695" cy="6858000"/>
+          </a:xfrm>
+          <a:prstGeom prst="rect">
+            <a:avLst/>
+          </a:prstGeom>
+          <a:solidFill>
+            <a:srgbClr val="0A1128"/>
+          </a:solidFill>
+          <a:ln>
+            <a:noFill/>
+          </a:ln>
+        </p:spPr>
+        <p:style>
+          <a:lnRef idx="1">
+            <a:schemeClr val="accent1"/>
+          </a:lnRef>
+          <a:fillRef idx="3">
+            <a:schemeClr val="accent1"/>
+          </a:fillRef>
+          <a:effectRef idx="2">
+            <a:schemeClr val="accent1"/>
+          </a:effectRef>
+          <a:fontRef idx="minor">
+            <a:schemeClr val="lt1"/>
+          </a:fontRef>
+        </p:style>
+        <p:txBody>
+          <a:bodyPr rtlCol="0" anchor="ctr"/>
+          <a:lstStyle/>
+          <a:p>
+            <a:pPr algn="ctr"/>
+          </a:p>
+        </p:txBody>
+      </p:sp>
+      <p:sp>
+        <p:nvSpPr>
+          <p:cNvPr id="3" name="Rectangle 2"/>
+          <p:cNvSpPr/>
+          <p:nvPr/>
+        </p:nvSpPr>
+        <p:spPr>
+          <a:xfrm>
+            <a:off x="731520" y="457200"/>
+            <a:ext cx="10728655" cy="54864"/>
+          </a:xfrm>
+          <a:prstGeom prst="rect">
+            <a:avLst/>
+          </a:prstGeom>
+          <a:solidFill>
+            <a:srgbClr val="00F0FF"/>
+          </a:solidFill>
+          <a:ln>
+            <a:noFill/>
+          </a:ln>
+        </p:spPr>
+        <p:style>
+          <a:lnRef idx="1">
+            <a:schemeClr val="accent1"/>
+          </a:lnRef>
+          <a:fillRef idx="3">
+            <a:schemeClr val="accent1"/>
+          </a:fillRef>
+          <a:effectRef idx="2">
+            <a:schemeClr val="accent1"/>
+          </a:effectRef>
+          <a:fontRef idx="minor">
+            <a:schemeClr val="lt1"/>
+          </a:fontRef>
+        </p:style>
+        <p:txBody>
+          <a:bodyPr rtlCol="0" anchor="ctr"/>
+          <a:lstStyle/>
+          <a:p>
+            <a:pPr algn="ctr"/>
+          </a:p>
+        </p:txBody>
+      </p:sp>
+      <p:sp>
+        <p:nvSpPr>
+          <p:cNvPr id="4" name="TextBox 3"/>
+          <p:cNvSpPr txBox="1"/>
+          <p:nvPr/>
+        </p:nvSpPr>
+        <p:spPr>
+          <a:xfrm>
+            <a:off x="731520" y="640080"/>
+            <a:ext cx="10728655" cy="1097280"/>
+          </a:xfrm>
+          <a:prstGeom prst="rect">
+            <a:avLst/>
+          </a:prstGeom>
+          <a:noFill/>
+        </p:spPr>
+        <p:txBody>
+          <a:bodyPr wrap="square">
+            <a:spAutoFit/>
+          </a:bodyPr>
+          <a:lstStyle/>
+          <a:p>
+            <a:pPr>
+              <a:defRPr sz="2400" b="1">
+                <a:solidFill>
+                  <a:srgbClr val="FFFFFF"/>
+                </a:solidFill>
+                <a:latin typeface="Arial"/>
+              </a:defRPr>
+            </a:pPr>
+            <a:r>
+              <a:t>Why Snapdragon Edge AI Wins (Competitive Advantage)</a:t>
+            </a:r>
+          </a:p>
+          <a:p>
+            <a:pPr>
+              <a:defRPr sz="1300">
+                <a:solidFill>
+                  <a:srgbClr val="00F0FF"/>
+                </a:solidFill>
+                <a:latin typeface="Arial"/>
+              </a:defRPr>
+            </a:pPr>
+            <a:r>
+              <a:t>OmniCare AI on Snapdragon X Elite vs Cloud Telemedicine vs Legacy Monitors</a:t>
+            </a:r>
+          </a:p>
+        </p:txBody>
+      </p:sp>
+      <p:graphicFrame>
+        <p:nvGraphicFramePr>
+          <p:cNvPr id="5" name="Table 4"/>
+          <p:cNvGraphicFramePr>
+            <a:graphicFrameLocks noGrp="1"/>
+          </p:cNvGraphicFramePr>
+          <p:nvPr/>
+        </p:nvGraphicFramePr>
+        <p:xfrm>
+          <a:off x="731520" y="1874519"/>
+          <a:ext cx="10728655" cy="4160520"/>
+        </p:xfrm>
+        <a:graphic>
+          <a:graphicData uri="http://schemas.openxmlformats.org/drawingml/2006/table">
+            <a:tbl>
+              <a:tblPr firstRow="1" bandRow="1">
+                <a:tableStyleId>{5C22544A-7EE6-4342-B048-85BDC9FD1C3A}</a:tableStyleId>
+              </a:tblPr>
+              <a:tblGrid>
+                <a:gridCol w="2011680"/>
+                <a:gridCol w="2468880"/>
+                <a:gridCol w="2651760"/>
+                <a:gridCol w="3596335"/>
+              </a:tblGrid>
+              <a:tr h="520065">
+                <a:tc>
+                  <a:txBody>
+                    <a:bodyPr/>
+                    <a:lstStyle/>
+                    <a:p>
+                      <a:pPr>
+                        <a:defRPr sz="1100" b="1">
+                          <a:solidFill>
+                            <a:srgbClr val="FFFFFF"/>
+                          </a:solidFill>
+                          <a:latin typeface="Arial"/>
+                        </a:defRPr>
+                      </a:pPr>
+                      <a:r>
+                        <a:t>Metric</a:t>
+                      </a:r>
+                    </a:p>
+                  </a:txBody>
+                  <a:tcPr>
+                    <a:solidFill>
+                      <a:srgbClr val="0052FF"/>
+                    </a:solidFill>
+                  </a:tcPr>
+                </a:tc>
+                <a:tc>
+                  <a:txBody>
+                    <a:bodyPr/>
+                    <a:lstStyle/>
+                    <a:p>
+                      <a:pPr>
+                        <a:defRPr sz="1100" b="1">
+                          <a:solidFill>
+                            <a:srgbClr val="FFFFFF"/>
+                          </a:solidFill>
+                          <a:latin typeface="Arial"/>
+                        </a:defRPr>
+                      </a:pPr>
+                      <a:r>
+                        <a:t>Legacy Hospital Devices</a:t>
+                      </a:r>
+                    </a:p>
+                  </a:txBody>
+                  <a:tcPr>
+                    <a:solidFill>
+                      <a:srgbClr val="0052FF"/>
+                    </a:solidFill>
+                  </a:tcPr>
+                </a:tc>
+                <a:tc>
+                  <a:txBody>
+                    <a:bodyPr/>
+                    <a:lstStyle/>
+                    <a:p>
+                      <a:pPr>
+                        <a:defRPr sz="1100" b="1">
+                          <a:solidFill>
+                            <a:srgbClr val="FFFFFF"/>
+                          </a:solidFill>
+                          <a:latin typeface="Arial"/>
+                        </a:defRPr>
+                      </a:pPr>
+                      <a:r>
+                        <a:t>Cloud Telehealth (AWS/GCP)</a:t>
+                      </a:r>
+                    </a:p>
+                  </a:txBody>
+                  <a:tcPr>
+                    <a:solidFill>
+                      <a:srgbClr val="0052FF"/>
+                    </a:solidFill>
+                  </a:tcPr>
+                </a:tc>
+                <a:tc>
+                  <a:txBody>
+                    <a:bodyPr/>
+                    <a:lstStyle/>
+                    <a:p>
+                      <a:pPr>
+                        <a:defRPr sz="1100" b="1">
+                          <a:solidFill>
+                            <a:srgbClr val="FFFFFF"/>
+                          </a:solidFill>
+                          <a:latin typeface="Arial"/>
+                        </a:defRPr>
+                      </a:pPr>
+                      <a:r>
+                        <a:t>OmniCare AI on Snapdragon</a:t>
+                      </a:r>
+                    </a:p>
+                  </a:txBody>
+                  <a:tcPr>
+                    <a:solidFill>
+                      <a:srgbClr val="00A0DC"/>
+                    </a:solidFill>
+                  </a:tcPr>
+                </a:tc>
+              </a:tr>
+              <a:tr h="520065">
+                <a:tc>
+                  <a:txBody>
+                    <a:bodyPr/>
+                    <a:lstStyle/>
+                    <a:p>
+                      <a:pPr>
+                        <a:defRPr sz="1000">
+                          <a:solidFill>
+                            <a:srgbClr val="FFFFFF"/>
+                          </a:solidFill>
+                          <a:latin typeface="Arial"/>
+                        </a:defRPr>
+                      </a:pPr>
+                      <a:r>
+                        <a:t>Edge AI Compute</a:t>
+                      </a:r>
+                    </a:p>
+                  </a:txBody>
+                  <a:tcPr>
+                    <a:solidFill>
+                      <a:srgbClr val="101C40"/>
+                    </a:solidFill>
+                  </a:tcPr>
+                </a:tc>
+                <a:tc>
+                  <a:txBody>
+                    <a:bodyPr/>
+                    <a:lstStyle/>
+                    <a:p>
+                      <a:pPr>
+                        <a:defRPr sz="1000">
+                          <a:solidFill>
+                            <a:srgbClr val="FFFFFF"/>
+                          </a:solidFill>
+                          <a:latin typeface="Arial"/>
+                        </a:defRPr>
+                      </a:pPr>
+                      <a:r>
+                        <a:t>None (Fixed microcontrollers)</a:t>
+                      </a:r>
+                    </a:p>
+                  </a:txBody>
+                  <a:tcPr>
+                    <a:solidFill>
+                      <a:srgbClr val="101C40"/>
+                    </a:solidFill>
+                  </a:tcPr>
+                </a:tc>
+                <a:tc>
+                  <a:txBody>
+                    <a:bodyPr/>
+                    <a:lstStyle/>
+                    <a:p>
+                      <a:pPr>
+                        <a:defRPr sz="1000">
+                          <a:solidFill>
+                            <a:srgbClr val="FFFFFF"/>
+                          </a:solidFill>
+                          <a:latin typeface="Arial"/>
+                        </a:defRPr>
+                      </a:pPr>
+                      <a:r>
+                        <a:t>None (Client is dumb display)</a:t>
+                      </a:r>
+                    </a:p>
+                  </a:txBody>
+                  <a:tcPr>
+                    <a:solidFill>
+                      <a:srgbClr val="101C40"/>
+                    </a:solidFill>
+                  </a:tcPr>
+                </a:tc>
+                <a:tc>
+                  <a:txBody>
+                    <a:bodyPr/>
+                    <a:lstStyle/>
+                    <a:p>
+                      <a:pPr>
+                        <a:defRPr sz="1000" b="1">
+                          <a:solidFill>
+                            <a:srgbClr val="00F0FF"/>
+                          </a:solidFill>
+                          <a:latin typeface="Arial"/>
+                        </a:defRPr>
+                      </a:pPr>
+                      <a:r>
+                        <a:t>45.0 TOPS Qualcomm Hexagon NPU</a:t>
+                      </a:r>
+                    </a:p>
+                  </a:txBody>
+                  <a:tcPr>
+                    <a:solidFill>
+                      <a:srgbClr val="101C40"/>
+                    </a:solidFill>
+                  </a:tcPr>
+                </a:tc>
+              </a:tr>
+              <a:tr h="520065">
+                <a:tc>
+                  <a:txBody>
+                    <a:bodyPr/>
+                    <a:lstStyle/>
+                    <a:p>
+                      <a:pPr>
+                        <a:defRPr sz="1000">
+                          <a:solidFill>
+                            <a:srgbClr val="FFFFFF"/>
+                          </a:solidFill>
+                          <a:latin typeface="Arial"/>
+                        </a:defRPr>
+                      </a:pPr>
+                      <a:r>
+                        <a:t>Diagnostic Latency</a:t>
+                      </a:r>
+                    </a:p>
+                  </a:txBody>
+                  <a:tcPr>
+                    <a:solidFill>
+                      <a:srgbClr val="162650"/>
+                    </a:solidFill>
+                  </a:tcPr>
+                </a:tc>
+                <a:tc>
+                  <a:txBody>
+                    <a:bodyPr/>
+                    <a:lstStyle/>
+                    <a:p>
+                      <a:pPr>
+                        <a:defRPr sz="1000">
+                          <a:solidFill>
+                            <a:srgbClr val="FFFFFF"/>
+                          </a:solidFill>
+                          <a:latin typeface="Arial"/>
+                        </a:defRPr>
+                      </a:pPr>
+                      <a:r>
+                        <a:t>Waveform display only (no AI)</a:t>
+                      </a:r>
+                    </a:p>
+                  </a:txBody>
+                  <a:tcPr>
+                    <a:solidFill>
+                      <a:srgbClr val="162650"/>
+                    </a:solidFill>
+                  </a:tcPr>
+                </a:tc>
+                <a:tc>
+                  <a:txBody>
+                    <a:bodyPr/>
+                    <a:lstStyle/>
+                    <a:p>
+                      <a:pPr>
+                        <a:defRPr sz="1000">
+                          <a:solidFill>
+                            <a:srgbClr val="FFFFFF"/>
+                          </a:solidFill>
+                          <a:latin typeface="Arial"/>
+                        </a:defRPr>
+                      </a:pPr>
+                      <a:r>
+                        <a:t>800ms - 2,500ms roundtrip lag</a:t>
+                      </a:r>
+                    </a:p>
+                  </a:txBody>
+                  <a:tcPr>
+                    <a:solidFill>
+                      <a:srgbClr val="162650"/>
+                    </a:solidFill>
+                  </a:tcPr>
+                </a:tc>
+                <a:tc>
+                  <a:txBody>
+                    <a:bodyPr/>
+                    <a:lstStyle/>
+                    <a:p>
+                      <a:pPr>
+                        <a:defRPr sz="1000" b="1">
+                          <a:solidFill>
+                            <a:srgbClr val="00F0FF"/>
+                          </a:solidFill>
+                          <a:latin typeface="Arial"/>
+                        </a:defRPr>
+                      </a:pPr>
+                      <a:r>
+                        <a:t>Sub-15ms multimodal inference</a:t>
+                      </a:r>
+                    </a:p>
+                  </a:txBody>
+                  <a:tcPr>
+                    <a:solidFill>
+                      <a:srgbClr val="162650"/>
+                    </a:solidFill>
+                  </a:tcPr>
+                </a:tc>
+              </a:tr>
+              <a:tr h="520065">
+                <a:tc>
+                  <a:txBody>
+                    <a:bodyPr/>
+                    <a:lstStyle/>
+                    <a:p>
+                      <a:pPr>
+                        <a:defRPr sz="1000">
+                          <a:solidFill>
+                            <a:srgbClr val="FFFFFF"/>
+                          </a:solidFill>
+                          <a:latin typeface="Arial"/>
+                        </a:defRPr>
+                      </a:pPr>
+                      <a:r>
+                        <a:t>Network Resilience</a:t>
+                      </a:r>
+                    </a:p>
+                  </a:txBody>
+                  <a:tcPr>
+                    <a:solidFill>
+                      <a:srgbClr val="101C40"/>
+                    </a:solidFill>
+                  </a:tcPr>
+                </a:tc>
+                <a:tc>
+                  <a:txBody>
+                    <a:bodyPr/>
+                    <a:lstStyle/>
+                    <a:p>
+                      <a:pPr>
+                        <a:defRPr sz="1000">
+                          <a:solidFill>
+                            <a:srgbClr val="FFFFFF"/>
+                          </a:solidFill>
+                          <a:latin typeface="Arial"/>
+                        </a:defRPr>
+                      </a:pPr>
+                      <a:r>
+                        <a:t>100% Offline (Manual readouts)</a:t>
+                      </a:r>
+                    </a:p>
+                  </a:txBody>
+                  <a:tcPr>
+                    <a:solidFill>
+                      <a:srgbClr val="101C40"/>
+                    </a:solidFill>
+                  </a:tcPr>
+                </a:tc>
+                <a:tc>
+                  <a:txBody>
+                    <a:bodyPr/>
+                    <a:lstStyle/>
+                    <a:p>
+                      <a:pPr>
+                        <a:defRPr sz="1000">
+                          <a:solidFill>
+                            <a:srgbClr val="FFFFFF"/>
+                          </a:solidFill>
+                          <a:latin typeface="Arial"/>
+                        </a:defRPr>
+                      </a:pPr>
+                      <a:r>
+                        <a:t>Fails completely without 4G/5G</a:t>
+                      </a:r>
+                    </a:p>
+                  </a:txBody>
+                  <a:tcPr>
+                    <a:solidFill>
+                      <a:srgbClr val="101C40"/>
+                    </a:solidFill>
+                  </a:tcPr>
+                </a:tc>
+                <a:tc>
+                  <a:txBody>
+                    <a:bodyPr/>
+                    <a:lstStyle/>
+                    <a:p>
+                      <a:pPr>
+                        <a:defRPr sz="1000" b="1">
+                          <a:solidFill>
+                            <a:srgbClr val="00F0FF"/>
+                          </a:solidFill>
+                          <a:latin typeface="Arial"/>
+                        </a:defRPr>
+                      </a:pPr>
+                      <a:r>
+                        <a:t>100% Zero Cloud Egress Offline</a:t>
+                      </a:r>
+                    </a:p>
+                  </a:txBody>
+                  <a:tcPr>
+                    <a:solidFill>
+                      <a:srgbClr val="101C40"/>
+                    </a:solidFill>
+                  </a:tcPr>
+                </a:tc>
+              </a:tr>
+              <a:tr h="520065">
+                <a:tc>
+                  <a:txBody>
+                    <a:bodyPr/>
+                    <a:lstStyle/>
+                    <a:p>
+                      <a:pPr>
+                        <a:defRPr sz="1000">
+                          <a:solidFill>
+                            <a:srgbClr val="FFFFFF"/>
+                          </a:solidFill>
+                          <a:latin typeface="Arial"/>
+                        </a:defRPr>
+                      </a:pPr>
+                      <a:r>
+                        <a:t>Hardware Investment</a:t>
+                      </a:r>
+                    </a:p>
+                  </a:txBody>
+                  <a:tcPr>
+                    <a:solidFill>
+                      <a:srgbClr val="162650"/>
+                    </a:solidFill>
+                  </a:tcPr>
+                </a:tc>
+                <a:tc>
+                  <a:txBody>
+                    <a:bodyPr/>
+                    <a:lstStyle/>
+                    <a:p>
+                      <a:pPr>
+                        <a:defRPr sz="1000">
+                          <a:solidFill>
+                            <a:srgbClr val="FFFFFF"/>
+                          </a:solidFill>
+                          <a:latin typeface="Arial"/>
+                        </a:defRPr>
+                      </a:pPr>
+                      <a:r>
+                        <a:t>$15,000+ (Multiple carts)</a:t>
+                      </a:r>
+                    </a:p>
+                  </a:txBody>
+                  <a:tcPr>
+                    <a:solidFill>
+                      <a:srgbClr val="162650"/>
+                    </a:solidFill>
+                  </a:tcPr>
+                </a:tc>
+                <a:tc>
+                  <a:txBody>
+                    <a:bodyPr/>
+                    <a:lstStyle/>
+                    <a:p>
+                      <a:pPr>
+                        <a:defRPr sz="1000">
+                          <a:solidFill>
+                            <a:srgbClr val="FFFFFF"/>
+                          </a:solidFill>
+                          <a:latin typeface="Arial"/>
+                        </a:defRPr>
+                      </a:pPr>
+                      <a:r>
+                        <a:t>$1,200 tablet + $50/mo cloud API</a:t>
+                      </a:r>
+                    </a:p>
+                  </a:txBody>
+                  <a:tcPr>
+                    <a:solidFill>
+                      <a:srgbClr val="162650"/>
+                    </a:solidFill>
+                  </a:tcPr>
+                </a:tc>
+                <a:tc>
+                  <a:txBody>
+                    <a:bodyPr/>
+                    <a:lstStyle/>
+                    <a:p>
+                      <a:pPr>
+                        <a:defRPr sz="1000" b="1">
+                          <a:solidFill>
+                            <a:srgbClr val="00F0FF"/>
+                          </a:solidFill>
+                          <a:latin typeface="Arial"/>
+                        </a:defRPr>
+                      </a:pPr>
+                      <a:r>
+                        <a:t>1 single HP PC replaces $15k hardware</a:t>
+                      </a:r>
+                    </a:p>
+                  </a:txBody>
+                  <a:tcPr>
+                    <a:solidFill>
+                      <a:srgbClr val="162650"/>
+                    </a:solidFill>
+                  </a:tcPr>
+                </a:tc>
+              </a:tr>
+              <a:tr h="520065">
+                <a:tc>
+                  <a:txBody>
+                    <a:bodyPr/>
+                    <a:lstStyle/>
+                    <a:p>
+                      <a:pPr>
+                        <a:defRPr sz="1000">
+                          <a:solidFill>
+                            <a:srgbClr val="FFFFFF"/>
+                          </a:solidFill>
+                          <a:latin typeface="Arial"/>
+                        </a:defRPr>
+                      </a:pPr>
+                      <a:r>
+                        <a:t>Off-Grid Battery</a:t>
+                      </a:r>
+                    </a:p>
+                  </a:txBody>
+                  <a:tcPr>
+                    <a:solidFill>
+                      <a:srgbClr val="101C40"/>
+                    </a:solidFill>
+                  </a:tcPr>
+                </a:tc>
+                <a:tc>
+                  <a:txBody>
+                    <a:bodyPr/>
+                    <a:lstStyle/>
+                    <a:p>
+                      <a:pPr>
+                        <a:defRPr sz="1000">
+                          <a:solidFill>
+                            <a:srgbClr val="FFFFFF"/>
+                          </a:solidFill>
+                          <a:latin typeface="Arial"/>
+                        </a:defRPr>
+                      </a:pPr>
+                      <a:r>
+                        <a:t>1-2 hours / AC power required</a:t>
+                      </a:r>
+                    </a:p>
+                  </a:txBody>
+                  <a:tcPr>
+                    <a:solidFill>
+                      <a:srgbClr val="101C40"/>
+                    </a:solidFill>
+                  </a:tcPr>
+                </a:tc>
+                <a:tc>
+                  <a:txBody>
+                    <a:bodyPr/>
+                    <a:lstStyle/>
+                    <a:p>
+                      <a:pPr>
+                        <a:defRPr sz="1000">
+                          <a:solidFill>
+                            <a:srgbClr val="FFFFFF"/>
+                          </a:solidFill>
+                          <a:latin typeface="Arial"/>
+                        </a:defRPr>
+                      </a:pPr>
+                      <a:r>
+                        <a:t>4-6 hours (tablets / iPads)</a:t>
+                      </a:r>
+                    </a:p>
+                  </a:txBody>
+                  <a:tcPr>
+                    <a:solidFill>
+                      <a:srgbClr val="101C40"/>
+                    </a:solidFill>
+                  </a:tcPr>
+                </a:tc>
+                <a:tc>
+                  <a:txBody>
+                    <a:bodyPr/>
+                    <a:lstStyle/>
+                    <a:p>
+                      <a:pPr>
+                        <a:defRPr sz="1000" b="1">
+                          <a:solidFill>
+                            <a:srgbClr val="00F0FF"/>
+                          </a:solidFill>
+                          <a:latin typeface="Arial"/>
+                        </a:defRPr>
+                      </a:pPr>
+                      <a:r>
+                        <a:t>26+ Hours (HP Smart Sense Eco)</a:t>
+                      </a:r>
+                    </a:p>
+                  </a:txBody>
+                  <a:tcPr>
+                    <a:solidFill>
+                      <a:srgbClr val="101C40"/>
+                    </a:solidFill>
+                  </a:tcPr>
+                </a:tc>
+              </a:tr>
+              <a:tr h="520065">
+                <a:tc>
+                  <a:txBody>
+                    <a:bodyPr/>
+                    <a:lstStyle/>
+                    <a:p>
+                      <a:pPr>
+                        <a:defRPr sz="1000">
+                          <a:solidFill>
+                            <a:srgbClr val="FFFFFF"/>
+                          </a:solidFill>
+                          <a:latin typeface="Arial"/>
+                        </a:defRPr>
+                      </a:pPr>
+                      <a:r>
+                        <a:t>Data Sovereignty</a:t>
+                      </a:r>
+                    </a:p>
+                  </a:txBody>
+                  <a:tcPr>
+                    <a:solidFill>
+                      <a:srgbClr val="162650"/>
+                    </a:solidFill>
+                  </a:tcPr>
+                </a:tc>
+                <a:tc>
+                  <a:txBody>
+                    <a:bodyPr/>
+                    <a:lstStyle/>
+                    <a:p>
+                      <a:pPr>
+                        <a:defRPr sz="1000">
+                          <a:solidFill>
+                            <a:srgbClr val="FFFFFF"/>
+                          </a:solidFill>
+                          <a:latin typeface="Arial"/>
+                        </a:defRPr>
+                      </a:pPr>
+                      <a:r>
+                        <a:t>Paper records (loss hazards)</a:t>
+                      </a:r>
+                    </a:p>
+                  </a:txBody>
+                  <a:tcPr>
+                    <a:solidFill>
+                      <a:srgbClr val="162650"/>
+                    </a:solidFill>
+                  </a:tcPr>
+                </a:tc>
+                <a:tc>
+                  <a:txBody>
+                    <a:bodyPr/>
+                    <a:lstStyle/>
+                    <a:p>
+                      <a:pPr>
+                        <a:defRPr sz="1000">
+                          <a:solidFill>
+                            <a:srgbClr val="FFFFFF"/>
+                          </a:solidFill>
+                          <a:latin typeface="Arial"/>
+                        </a:defRPr>
+                      </a:pPr>
+                      <a:r>
+                        <a:t>High risk of cloud leakage</a:t>
+                      </a:r>
+                    </a:p>
+                  </a:txBody>
+                  <a:tcPr>
+                    <a:solidFill>
+                      <a:srgbClr val="162650"/>
+                    </a:solidFill>
+                  </a:tcPr>
+                </a:tc>
+                <a:tc>
+                  <a:txBody>
+                    <a:bodyPr/>
+                    <a:lstStyle/>
+                    <a:p>
+                      <a:pPr>
+                        <a:defRPr sz="1000" b="1">
+                          <a:solidFill>
+                            <a:srgbClr val="00F0FF"/>
+                          </a:solidFill>
+                          <a:latin typeface="Arial"/>
+                        </a:defRPr>
+                      </a:pPr>
+                      <a:r>
+                        <a:t>Hardware Wolf Vault (DPDP Act 2023)</a:t>
+                      </a:r>
+                    </a:p>
+                  </a:txBody>
+                  <a:tcPr>
+                    <a:solidFill>
+                      <a:srgbClr val="162650"/>
+                    </a:solidFill>
+                  </a:tcPr>
+                </a:tc>
+              </a:tr>
+              <a:tr h="520065">
+                <a:tc>
+                  <a:txBody>
+                    <a:bodyPr/>
+                    <a:lstStyle/>
+                    <a:p>
+                      <a:pPr>
+                        <a:defRPr sz="1000">
+                          <a:solidFill>
+                            <a:srgbClr val="FFFFFF"/>
+                          </a:solidFill>
+                          <a:latin typeface="Arial"/>
+                        </a:defRPr>
+                      </a:pPr>
+                      <a:r>
+                        <a:t>Drug Cost Savings</a:t>
+                      </a:r>
+                    </a:p>
+                  </a:txBody>
+                  <a:tcPr>
+                    <a:solidFill>
+                      <a:srgbClr val="101C40"/>
+                    </a:solidFill>
+                  </a:tcPr>
+                </a:tc>
+                <a:tc>
+                  <a:txBody>
+                    <a:bodyPr/>
+                    <a:lstStyle/>
+                    <a:p>
+                      <a:pPr>
+                        <a:defRPr sz="1000">
+                          <a:solidFill>
+                            <a:srgbClr val="FFFFFF"/>
+                          </a:solidFill>
+                          <a:latin typeface="Arial"/>
+                        </a:defRPr>
+                      </a:pPr>
+                      <a:r>
+                        <a:t>None (Out-of-pocket burden)</a:t>
+                      </a:r>
+                    </a:p>
+                  </a:txBody>
+                  <a:tcPr>
+                    <a:solidFill>
+                      <a:srgbClr val="101C40"/>
+                    </a:solidFill>
+                  </a:tcPr>
+                </a:tc>
+                <a:tc>
+                  <a:txBody>
+                    <a:bodyPr/>
+                    <a:lstStyle/>
+                    <a:p>
+                      <a:pPr>
+                        <a:defRPr sz="1000">
+                          <a:solidFill>
+                            <a:srgbClr val="FFFFFF"/>
+                          </a:solidFill>
+                          <a:latin typeface="Arial"/>
+                        </a:defRPr>
+                      </a:pPr>
+                      <a:r>
+                        <a:t>None (Static prescription PDFs)</a:t>
+                      </a:r>
+                    </a:p>
+                  </a:txBody>
+                  <a:tcPr>
+                    <a:solidFill>
+                      <a:srgbClr val="101C40"/>
+                    </a:solidFill>
+                  </a:tcPr>
+                </a:tc>
+                <a:tc>
+                  <a:txBody>
+                    <a:bodyPr/>
+                    <a:lstStyle/>
+                    <a:p>
+                      <a:pPr>
+                        <a:defRPr sz="1000" b="1">
+                          <a:solidFill>
+                            <a:srgbClr val="00F0FF"/>
+                          </a:solidFill>
+                          <a:latin typeface="Arial"/>
+                        </a:defRPr>
+                      </a:pPr>
+                      <a:r>
+                        <a:t>82.9% generic savings via PMBJP</a:t>
+                      </a:r>
+                    </a:p>
+                  </a:txBody>
+                  <a:tcPr>
+                    <a:solidFill>
+                      <a:srgbClr val="101C40"/>
+                    </a:solidFill>
+                  </a:tcPr>
+                </a:tc>
+              </a:tr>
+            </a:tbl>
+          </a:graphicData>
+        </a:graphic>
+      </p:graphicFrame>
+      <p:sp>
+        <p:nvSpPr>
+          <p:cNvPr id="6" name="TextBox 5"/>
+          <p:cNvSpPr txBox="1"/>
+          <p:nvPr/>
+        </p:nvSpPr>
+        <p:spPr>
+          <a:xfrm>
+            <a:off x="731520" y="6217920"/>
+            <a:ext cx="10728655" cy="365760"/>
+          </a:xfrm>
+          <a:prstGeom prst="rect">
+            <a:avLst/>
+          </a:prstGeom>
+          <a:noFill/>
+        </p:spPr>
+        <p:txBody>
+          <a:bodyPr wrap="none">
+            <a:spAutoFit/>
+          </a:bodyPr>
+          <a:lstStyle/>
+          <a:p>
+            <a:pPr>
+              <a:defRPr sz="950">
+                <a:solidFill>
+                  <a:srgbClr val="B4BED2"/>
+                </a:solidFill>
+                <a:latin typeface="Arial"/>
+              </a:defRPr>
+            </a:pPr>
+            <a:r>
+              <a:t>Competitive Moat: Why Snapdragon X Elite is Uniquely Positioned to Dominate Edge Healthcare</a:t>
+            </a:r>
+          </a:p>
+        </p:txBody>
+      </p:sp>
+    </p:spTree>
+  </p:cSld>
+  <p:clrMapOvr>
+    <a:masterClrMapping/>
+  </p:clrMapOvr>
+</p:sld>
+</file>
+
+<file path=ppt/slides/slide12.xml><?xml version="1.0" encoding="utf-8"?>
 <p:sld xmlns:a="http://schemas.openxmlformats.org/drawingml/2006/main" xmlns:p="http://schemas.openxmlformats.org/presentationml/2006/main" xmlns:r="http://schemas.openxmlformats.org/officeDocument/2006/relationships">
   <p:cSld>
     <p:spTree>

</xml_diff>

<commit_message>
fix(presentation): resolve text formatting, typography scaling, character encodings, and layout across Short Pitch Presentation PDF and PPTX
</commit_message>
<xml_diff>
--- a/submission_files/OmniCare_AI_Executive_Presentation.pptx
+++ b/submission_files/OmniCare_AI_Executive_Presentation.pptx
@@ -5383,7 +5383,7 @@
           <a:p>
             <a:pPr>
               <a:spcBef>
-                <a:spcPts val="600"/>
+                <a:spcPts val="500"/>
               </a:spcBef>
             </a:pPr>
             <a:r>
@@ -5393,22 +5393,31 @@
                 </a:solidFill>
                 <a:latin typeface="Segoe UI"/>
               </a:rPr>
-              <a:t>✓ Sub-15ms Multimodal Latency         </a:t>
+              <a:t>[PASS] </a:t>
             </a:r>
             <a:r>
               <a:rPr b="1" sz="950">
                 <a:solidFill>
-                  <a:srgbClr val="00E5FF"/>
+                  <a:srgbClr val="F1F5F9"/>
                 </a:solidFill>
                 <a:latin typeface="Segoe UI"/>
               </a:rPr>
-              <a:t>✓ 26+ Hours Off-Grid Battery</a:t>
+              <a:t>Sub-15ms Multimodal Latency   •   </a:t>
+            </a:r>
+            <a:r>
+              <a:rPr b="1" sz="950">
+                <a:solidFill>
+                  <a:srgbClr val="00E5FF"/>
+                </a:solidFill>
+                <a:latin typeface="Segoe UI"/>
+              </a:rPr>
+              <a:t>26+ Hours Off-Grid Battery</a:t>
             </a:r>
           </a:p>
           <a:p>
             <a:pPr>
               <a:spcBef>
-                <a:spcPts val="600"/>
+                <a:spcPts val="500"/>
               </a:spcBef>
             </a:pPr>
             <a:r>
@@ -5418,22 +5427,31 @@
                 </a:solidFill>
                 <a:latin typeface="Segoe UI"/>
               </a:rPr>
-              <a:t>✓ DPDP Act 2023 Compliant             </a:t>
+              <a:t>[PASS] </a:t>
             </a:r>
             <a:r>
               <a:rPr b="1" sz="950">
                 <a:solidFill>
-                  <a:srgbClr val="00E5FF"/>
+                  <a:srgbClr val="F1F5F9"/>
                 </a:solidFill>
                 <a:latin typeface="Segoe UI"/>
               </a:rPr>
-              <a:t>✓ 82.9% Jan Aushadhi Savings</a:t>
+              <a:t>DPDP Act 2023 Compliant   •   </a:t>
+            </a:r>
+            <a:r>
+              <a:rPr b="1" sz="950">
+                <a:solidFill>
+                  <a:srgbClr val="00E5FF"/>
+                </a:solidFill>
+                <a:latin typeface="Segoe UI"/>
+              </a:rPr>
+              <a:t>82.9% Jan Aushadhi Savings</a:t>
             </a:r>
           </a:p>
           <a:p>
             <a:pPr>
               <a:spcBef>
-                <a:spcPts val="600"/>
+                <a:spcPts val="500"/>
               </a:spcBef>
             </a:pPr>
             <a:r>
@@ -5443,16 +5461,25 @@
                 </a:solidFill>
                 <a:latin typeface="Segoe UI"/>
               </a:rPr>
-              <a:t>✓ 35/35 Quality Gates PASS            </a:t>
+              <a:t>[PASS] </a:t>
             </a:r>
             <a:r>
               <a:rPr b="1" sz="950">
                 <a:solidFill>
-                  <a:srgbClr val="00E5FF"/>
+                  <a:srgbClr val="F1F5F9"/>
                 </a:solidFill>
                 <a:latin typeface="Segoe UI"/>
               </a:rPr>
-              <a:t>✓ 100% Offline Standalone Resilience</a:t>
+              <a:t>35/35 Quality Gates PASS   •   </a:t>
+            </a:r>
+            <a:r>
+              <a:rPr b="1" sz="950">
+                <a:solidFill>
+                  <a:srgbClr val="00E5FF"/>
+                </a:solidFill>
+                <a:latin typeface="Segoe UI"/>
+              </a:rPr>
+              <a:t>100% Offline Standalone Resilience</a:t>
             </a:r>
           </a:p>
         </p:txBody>
@@ -5696,7 +5723,7 @@
                 </a:solidFill>
                 <a:latin typeface="Segoe UI"/>
               </a:rPr>
-              <a:t>⚡ Qualcomm Snapdragon® X Elite (12-Core Oryon) • 45.0 TOPS Hexagon NPU</a:t>
+              <a:t>• Qualcomm Snapdragon® X Elite (12-Core Oryon) • 45.0 TOPS Hexagon NPU</a:t>
             </a:r>
           </a:p>
           <a:p>
@@ -5712,7 +5739,7 @@
                 </a:solidFill>
                 <a:latin typeface="Segoe UI"/>
               </a:rPr>
-              <a:t>🔒 HP Wolf Security Hardware Enclave (AES-256-GCM) • 26+ Hours Battery</a:t>
+              <a:t>• HP Wolf Security Hardware Enclave (AES-256-GCM) • 26+ Hours Battery</a:t>
             </a:r>
           </a:p>
         </p:txBody>
@@ -6335,9 +6362,9 @@
                     <a:lstStyle/>
                     <a:p>
                       <a:r>
-                        <a:rPr sz="950">
+                        <a:rPr sz="950" b="1">
                           <a:solidFill>
-                            <a:srgbClr val="F1F5F9"/>
+                            <a:srgbClr val="FFFFFF"/>
                           </a:solidFill>
                           <a:latin typeface="Segoe UI"/>
                         </a:rPr>
@@ -6425,9 +6452,9 @@
                     <a:lstStyle/>
                     <a:p>
                       <a:r>
-                        <a:rPr sz="950">
+                        <a:rPr sz="950" b="1">
                           <a:solidFill>
-                            <a:srgbClr val="F1F5F9"/>
+                            <a:srgbClr val="FFFFFF"/>
                           </a:solidFill>
                           <a:latin typeface="Segoe UI"/>
                         </a:rPr>
@@ -6515,9 +6542,9 @@
                     <a:lstStyle/>
                     <a:p>
                       <a:r>
-                        <a:rPr sz="950">
+                        <a:rPr sz="950" b="1">
                           <a:solidFill>
-                            <a:srgbClr val="F1F5F9"/>
+                            <a:srgbClr val="FFFFFF"/>
                           </a:solidFill>
                           <a:latin typeface="Segoe UI"/>
                         </a:rPr>
@@ -6605,9 +6632,9 @@
                     <a:lstStyle/>
                     <a:p>
                       <a:r>
-                        <a:rPr sz="950">
+                        <a:rPr sz="950" b="1">
                           <a:solidFill>
-                            <a:srgbClr val="F1F5F9"/>
+                            <a:srgbClr val="FFFFFF"/>
                           </a:solidFill>
                           <a:latin typeface="Segoe UI"/>
                         </a:rPr>
@@ -6695,9 +6722,9 @@
                     <a:lstStyle/>
                     <a:p>
                       <a:r>
-                        <a:rPr sz="950">
+                        <a:rPr sz="950" b="1">
                           <a:solidFill>
-                            <a:srgbClr val="F1F5F9"/>
+                            <a:srgbClr val="FFFFFF"/>
                           </a:solidFill>
                           <a:latin typeface="Segoe UI"/>
                         </a:rPr>
@@ -6785,9 +6812,9 @@
                     <a:lstStyle/>
                     <a:p>
                       <a:r>
-                        <a:rPr sz="950">
+                        <a:rPr sz="950" b="1">
                           <a:solidFill>
-                            <a:srgbClr val="F1F5F9"/>
+                            <a:srgbClr val="FFFFFF"/>
                           </a:solidFill>
                           <a:latin typeface="Segoe UI"/>
                         </a:rPr>
@@ -6875,9 +6902,9 @@
                     <a:lstStyle/>
                     <a:p>
                       <a:r>
-                        <a:rPr sz="950">
+                        <a:rPr sz="950" b="1">
                           <a:solidFill>
-                            <a:srgbClr val="F1F5F9"/>
+                            <a:srgbClr val="FFFFFF"/>
                           </a:solidFill>
                           <a:latin typeface="Segoe UI"/>
                         </a:rPr>
@@ -8330,7 +8357,7 @@
           <a:p>
             <a:pPr>
               <a:spcBef>
-                <a:spcPts val="400"/>
+                <a:spcPts val="300"/>
               </a:spcBef>
             </a:pPr>
             <a:r>
@@ -8342,8 +8369,20 @@
               </a:rPr>
               <a:t>Open showcase/index.html in browser.</a:t>
             </a:r>
-            <a:br/>
-            <a:r>
+          </a:p>
+          <a:p>
+            <a:pPr>
+              <a:spcBef>
+                <a:spcPts val="300"/>
+              </a:spcBef>
+            </a:pPr>
+            <a:r>
+              <a:rPr sz="1000">
+                <a:solidFill>
+                  <a:srgbClr val="F1F5F9"/>
+                </a:solidFill>
+                <a:latin typeface="Segoe UI"/>
+              </a:rPr>
               <a:t>Test 4 clinical scenarios 100% offline.</a:t>
             </a:r>
           </a:p>
@@ -8472,7 +8511,7 @@
           <a:p>
             <a:pPr>
               <a:spcBef>
-                <a:spcPts val="400"/>
+                <a:spcPts val="300"/>
               </a:spcBef>
             </a:pPr>
             <a:r>
@@ -8484,12 +8523,36 @@
               </a:rPr>
               <a:t>Run .\launch_omnicare.ps1</a:t>
             </a:r>
-            <a:br/>
-            <a:r>
+          </a:p>
+          <a:p>
+            <a:pPr>
+              <a:spcBef>
+                <a:spcPts val="300"/>
+              </a:spcBef>
+            </a:pPr>
+            <a:r>
+              <a:rPr sz="1000">
+                <a:solidFill>
+                  <a:srgbClr val="F1F5F9"/>
+                </a:solidFill>
+                <a:latin typeface="Segoe UI"/>
+              </a:rPr>
               <a:t>Open http://localhost:8000/docs</a:t>
             </a:r>
-            <a:br/>
-            <a:r>
+          </a:p>
+          <a:p>
+            <a:pPr>
+              <a:spcBef>
+                <a:spcPts val="300"/>
+              </a:spcBef>
+            </a:pPr>
+            <a:r>
+              <a:rPr sz="1000">
+                <a:solidFill>
+                  <a:srgbClr val="F1F5F9"/>
+                </a:solidFill>
+                <a:latin typeface="Segoe UI"/>
+              </a:rPr>
               <a:t>Open frontend/index.html</a:t>
             </a:r>
           </a:p>
@@ -8618,7 +8681,7 @@
           <a:p>
             <a:pPr>
               <a:spcBef>
-                <a:spcPts val="400"/>
+                <a:spcPts val="300"/>
               </a:spcBef>
             </a:pPr>
             <a:r>
@@ -8630,8 +8693,20 @@
               </a:rPr>
               <a:t>python verify_all.py</a:t>
             </a:r>
-            <a:br/>
-            <a:r>
+          </a:p>
+          <a:p>
+            <a:pPr>
+              <a:spcBef>
+                <a:spcPts val="300"/>
+              </a:spcBef>
+            </a:pPr>
+            <a:r>
+              <a:rPr sz="1000">
+                <a:solidFill>
+                  <a:srgbClr val="F1F5F9"/>
+                </a:solidFill>
+                <a:latin typeface="Segoe UI"/>
+              </a:rPr>
               <a:t>All 35 gates pass cleanly (EXIT CODE 0)</a:t>
             </a:r>
           </a:p>
@@ -15523,9 +15598,15 @@
                 </a:solidFill>
                 <a:latin typeface="Segoe UI"/>
               </a:rPr>
-              <a:t>CDSCO SaMD MDR-2017 Class B Aligned:
-</a:t>
-            </a:r>
+              <a:t>CDSCO SaMD MDR-2017 Class B Aligned:</a:t>
+            </a:r>
+          </a:p>
+          <a:p>
+            <a:pPr>
+              <a:spcBef>
+                <a:spcPts val="200"/>
+              </a:spcBef>
+            </a:pPr>
             <a:r>
               <a:rPr sz="950">
                 <a:solidFill>
@@ -15655,9 +15736,15 @@
                 </a:solidFill>
                 <a:latin typeface="Segoe UI"/>
               </a:rPr>
-              <a:t>Emergency Escalation Pathways:
-</a:t>
-            </a:r>
+              <a:t>Emergency Escalation Pathways:</a:t>
+            </a:r>
+          </a:p>
+          <a:p>
+            <a:pPr>
+              <a:spcBef>
+                <a:spcPts val="200"/>
+              </a:spcBef>
+            </a:pPr>
             <a:r>
               <a:rPr sz="950">
                 <a:solidFill>
@@ -15787,9 +15874,15 @@
                 </a:solidFill>
                 <a:latin typeface="Segoe UI"/>
               </a:rPr>
-              <a:t>Multilingual Voice Dictation:
-</a:t>
-            </a:r>
+              <a:t>Multilingual Voice Dictation:</a:t>
+            </a:r>
+          </a:p>
+          <a:p>
+            <a:pPr>
+              <a:spcBef>
+                <a:spcPts val="200"/>
+              </a:spcBef>
+            </a:pPr>
             <a:r>
               <a:rPr sz="950">
                 <a:solidFill>
@@ -15919,9 +16012,15 @@
                 </a:solidFill>
                 <a:latin typeface="Segoe UI"/>
               </a:rPr>
-              <a:t>Automated SOAP Notes:
-</a:t>
-            </a:r>
+              <a:t>Automated SOAP Notes:</a:t>
+            </a:r>
+          </a:p>
+          <a:p>
+            <a:pPr>
+              <a:spcBef>
+                <a:spcPts val="200"/>
+              </a:spcBef>
+            </a:pPr>
             <a:r>
               <a:rPr sz="950">
                 <a:solidFill>
@@ -19148,13 +19247,13 @@
               </a:spcBef>
             </a:pPr>
             <a:r>
-              <a:rPr b="1" sz="1000">
+              <a:rPr b="1" sz="1100">
                 <a:solidFill>
                   <a:srgbClr val="10B981"/>
                 </a:solidFill>
                 <a:latin typeface="Segoe UI"/>
               </a:rPr>
-              <a:t>✓ </a:t>
+              <a:t>• </a:t>
             </a:r>
             <a:r>
               <a:rPr sz="1000">
@@ -19173,13 +19272,13 @@
               </a:spcBef>
             </a:pPr>
             <a:r>
-              <a:rPr b="1" sz="1000">
+              <a:rPr b="1" sz="1100">
                 <a:solidFill>
                   <a:srgbClr val="10B981"/>
                 </a:solidFill>
                 <a:latin typeface="Segoe UI"/>
               </a:rPr>
-              <a:t>✓ </a:t>
+              <a:t>• </a:t>
             </a:r>
             <a:r>
               <a:rPr sz="1000">
@@ -19198,13 +19297,13 @@
               </a:spcBef>
             </a:pPr>
             <a:r>
-              <a:rPr b="1" sz="1000">
+              <a:rPr b="1" sz="1100">
                 <a:solidFill>
                   <a:srgbClr val="10B981"/>
                 </a:solidFill>
                 <a:latin typeface="Segoe UI"/>
               </a:rPr>
-              <a:t>✓ </a:t>
+              <a:t>• </a:t>
             </a:r>
             <a:r>
               <a:rPr sz="1000">
@@ -19223,13 +19322,13 @@
               </a:spcBef>
             </a:pPr>
             <a:r>
-              <a:rPr b="1" sz="1000">
+              <a:rPr b="1" sz="1100">
                 <a:solidFill>
                   <a:srgbClr val="10B981"/>
                 </a:solidFill>
                 <a:latin typeface="Segoe UI"/>
               </a:rPr>
-              <a:t>✓ </a:t>
+              <a:t>• </a:t>
             </a:r>
             <a:r>
               <a:rPr sz="1000">

</xml_diff>